<commit_message>
docs(comercial): módulo financiero (plan) + T&C + baja comisiones de aliados
- Plan de diseño del módulo financiero: desactivación de tenants por
  vencimiento de suscripción (fecha inicio/fin, estado, antigüedad, gracia
  parametrizable por SuperAdmin), cron diario, gate de acceso (cierra el gap
  actual: hoy un usuario logueado no pierde acceso al desactivar el tenant).
- Documento plano de Términos y Condiciones: suscripciones (todos los planes)
  + Programa de Aliados.
- Aliados: bajo las comisiones (Referido 15→10%, Comercial 25→15%, Premium
  35→20%); recalculo de ejemplos; presentación PPTX regenerada + correo.

Co-Authored-By: Claude Opus 4.8 (1M context) <noreply@anthropic.com>
</commit_message>
<xml_diff>
--- a/docs/demos/presentacion/ExamLab-Presentacion-Aliados.pptx
+++ b/docs/demos/presentacion/ExamLab-Presentacion-Aliados.pptx
@@ -2428,7 +2428,7 @@
                   <a:srgbClr val="7C3AED"/>
                 </a:solidFill>
               </a:rPr>
-              <a:t>15%</a:t>
+              <a:t>10%</a:t>
             </a:r>
             <a:endParaRPr lang="en-US" sz="4000" dirty="0"/>
           </a:p>
@@ -2765,7 +2765,7 @@
                   <a:srgbClr val="059669"/>
                 </a:solidFill>
               </a:rPr>
-              <a:t>25%</a:t>
+              <a:t>15%</a:t>
             </a:r>
             <a:endParaRPr lang="en-US" sz="4000" dirty="0"/>
           </a:p>
@@ -3055,7 +3055,7 @@
                   <a:srgbClr val="4F46E5"/>
                 </a:solidFill>
               </a:rPr>
-              <a:t>35%</a:t>
+              <a:t>20%</a:t>
             </a:r>
             <a:endParaRPr lang="en-US" sz="4000" dirty="0"/>
           </a:p>
@@ -3873,7 +3873,7 @@
                             <a:srgbClr val="334155"/>
                           </a:solidFill>
                         </a:rPr>
-                        <a:t>15% del primer año</a:t>
+                        <a:t>10% del primer año</a:t>
                       </a:r>
                       <a:endParaRPr lang="en-US" sz="1200" dirty="0"/>
                     </a:p>
@@ -3931,7 +3931,7 @@
                             <a:srgbClr val="B45309"/>
                           </a:solidFill>
                         </a:rPr>
-                        <a:t>$1.800 una vez</a:t>
+                        <a:t>$1.200 una vez</a:t>
                       </a:r>
                       <a:endParaRPr lang="en-US" sz="1300" dirty="0"/>
                     </a:p>
@@ -4110,7 +4110,7 @@
                             <a:srgbClr val="334155"/>
                           </a:solidFill>
                         </a:rPr>
-                        <a:t>25% recurrente</a:t>
+                        <a:t>15% recurrente</a:t>
                       </a:r>
                       <a:endParaRPr lang="en-US" sz="1200" dirty="0"/>
                     </a:p>
@@ -4168,7 +4168,7 @@
                             <a:srgbClr val="059669"/>
                           </a:solidFill>
                         </a:rPr>
-                        <a:t>~$75/mes (~$897/año)</a:t>
+                        <a:t>~$45/mes (~$538/año)</a:t>
                       </a:r>
                       <a:endParaRPr lang="en-US" sz="1300" dirty="0"/>
                     </a:p>
@@ -4344,7 +4344,7 @@
                             <a:srgbClr val="334155"/>
                           </a:solidFill>
                         </a:rPr>
-                        <a:t>25% recurrente</a:t>
+                        <a:t>15% recurrente</a:t>
                       </a:r>
                       <a:endParaRPr lang="en-US" sz="1200" dirty="0"/>
                     </a:p>
@@ -4402,7 +4402,7 @@
                             <a:srgbClr val="059669"/>
                           </a:solidFill>
                         </a:rPr>
-                        <a:t>$750/mes ($9.000/año)</a:t>
+                        <a:t>$450/mes ($5.400/año)</a:t>
                       </a:r>
                       <a:endParaRPr lang="en-US" sz="1300" dirty="0"/>
                     </a:p>
@@ -4578,7 +4578,7 @@
                             <a:srgbClr val="334155"/>
                           </a:solidFill>
                         </a:rPr>
-                        <a:t>35% recurrente</a:t>
+                        <a:t>20% recurrente</a:t>
                       </a:r>
                       <a:endParaRPr lang="en-US" sz="1200" dirty="0"/>
                     </a:p>
@@ -4636,7 +4636,7 @@
                             <a:srgbClr val="059669"/>
                           </a:solidFill>
                         </a:rPr>
-                        <a:t>$350/mes ($4.200/año)</a:t>
+                        <a:t>$200/mes ($2.400/año)</a:t>
                       </a:r>
                       <a:endParaRPr lang="en-US" sz="1300" dirty="0"/>
                     </a:p>

</xml_diff>

<commit_message>
fix(demos): preservar la imagen del pptx de Aliados al actualizar precios v3
El commit anterior reescribió ExamLab-Presentacion-Aliados.pptx con python-pptx,
que al re-guardar DESCARTÓ la imagen embebida (172KB→36KB, media 1→0). Rehecho con
edición a nivel ZIP-XML sobre el original: solo se reemplaza el texto de precios en
las diapositivas, preservando media y formato byte-a-byte (media 1, 172KB).

Co-Authored-By: Claude Opus 4.8 (1M context) <noreply@anthropic.com>
</commit_message>
<xml_diff>
--- a/docs/demos/presentacion/ExamLab-Presentacion-Aliados.pptx
+++ b/docs/demos/presentacion/ExamLab-Presentacion-Aliados.pptx
@@ -1517,10 +1517,6 @@
           </a:solidFill>
           <a:ln/>
         </p:spPr>
-        <p:txBody>
-          <a:bodyPr/>
-          <a:p/>
-        </p:txBody>
       </p:sp>
       <p:sp>
         <p:nvSpPr>
@@ -1541,10 +1537,6 @@
           </a:solidFill>
           <a:ln/>
         </p:spPr>
-        <p:txBody>
-          <a:bodyPr/>
-          <a:p/>
-        </p:txBody>
       </p:sp>
       <p:sp>
         <p:nvSpPr>
@@ -1741,10 +1733,6 @@
           </a:solidFill>
           <a:ln/>
         </p:spPr>
-        <p:txBody>
-          <a:bodyPr/>
-          <a:p/>
-        </p:txBody>
       </p:sp>
       <p:sp>
         <p:nvSpPr>
@@ -1765,10 +1753,6 @@
           </a:solidFill>
           <a:ln/>
         </p:spPr>
-        <p:txBody>
-          <a:bodyPr/>
-          <a:p/>
-        </p:txBody>
       </p:sp>
       <p:sp>
         <p:nvSpPr>
@@ -1995,10 +1979,6 @@
             <a:prstDash val="solid"/>
           </a:ln>
         </p:spPr>
-        <p:txBody>
-          <a:bodyPr/>
-          <a:p/>
-        </p:txBody>
       </p:sp>
       <p:sp>
         <p:nvSpPr>
@@ -2066,10 +2046,6 @@
           </a:solidFill>
           <a:ln/>
         </p:spPr>
-        <p:txBody>
-          <a:bodyPr/>
-          <a:p/>
-        </p:txBody>
       </p:sp>
       <p:sp>
         <p:nvSpPr>
@@ -2194,10 +2170,6 @@
           </a:solidFill>
           <a:ln/>
         </p:spPr>
-        <p:txBody>
-          <a:bodyPr/>
-          <a:p/>
-        </p:txBody>
       </p:sp>
       <p:sp>
         <p:nvSpPr>
@@ -2333,10 +2305,6 @@
             <a:prstDash val="solid"/>
           </a:ln>
         </p:spPr>
-        <p:txBody>
-          <a:bodyPr/>
-          <a:p/>
-        </p:txBody>
       </p:sp>
       <p:sp>
         <p:nvSpPr>
@@ -2357,10 +2325,6 @@
           </a:solidFill>
           <a:ln/>
         </p:spPr>
-        <p:txBody>
-          <a:bodyPr/>
-          <a:p/>
-        </p:txBody>
       </p:sp>
       <p:sp>
         <p:nvSpPr>
@@ -2528,10 +2492,6 @@
             <a:prstDash val="solid"/>
           </a:ln>
         </p:spPr>
-        <p:txBody>
-          <a:bodyPr/>
-          <a:p/>
-        </p:txBody>
       </p:sp>
       <p:sp>
         <p:nvSpPr>
@@ -2642,10 +2602,6 @@
             </a:outerShdw>
           </a:effectLst>
         </p:spPr>
-        <p:txBody>
-          <a:bodyPr/>
-          <a:p/>
-        </p:txBody>
       </p:sp>
       <p:sp>
         <p:nvSpPr>
@@ -2706,10 +2662,6 @@
           </a:solidFill>
           <a:ln/>
         </p:spPr>
-        <p:txBody>
-          <a:bodyPr/>
-          <a:p/>
-        </p:txBody>
       </p:sp>
       <p:sp>
         <p:nvSpPr>
@@ -2877,10 +2829,6 @@
             <a:prstDash val="solid"/>
           </a:ln>
         </p:spPr>
-        <p:txBody>
-          <a:bodyPr/>
-          <a:p/>
-        </p:txBody>
       </p:sp>
       <p:sp>
         <p:nvSpPr>
@@ -2984,10 +2932,6 @@
             <a:prstDash val="solid"/>
           </a:ln>
         </p:spPr>
-        <p:txBody>
-          <a:bodyPr/>
-          <a:p/>
-        </p:txBody>
       </p:sp>
       <p:sp>
         <p:nvSpPr>
@@ -3008,10 +2952,6 @@
           </a:solidFill>
           <a:ln/>
         </p:spPr>
-        <p:txBody>
-          <a:bodyPr/>
-          <a:p/>
-        </p:txBody>
       </p:sp>
       <p:sp>
         <p:nvSpPr>
@@ -3179,10 +3119,6 @@
             <a:prstDash val="solid"/>
           </a:ln>
         </p:spPr>
-        <p:txBody>
-          <a:bodyPr/>
-          <a:p/>
-        </p:txBody>
       </p:sp>
       <p:sp>
         <p:nvSpPr>
@@ -3315,10 +3251,6 @@
           </a:solidFill>
           <a:ln/>
         </p:spPr>
-        <p:txBody>
-          <a:bodyPr/>
-          <a:p/>
-        </p:txBody>
       </p:sp>
       <p:sp>
         <p:nvSpPr>
@@ -3443,10 +3375,6 @@
           </a:solidFill>
           <a:ln/>
         </p:spPr>
-        <p:txBody>
-          <a:bodyPr/>
-          <a:p/>
-        </p:txBody>
       </p:sp>
       <p:sp>
         <p:nvSpPr>
@@ -3467,10 +3395,6 @@
           </a:solidFill>
           <a:ln/>
         </p:spPr>
-        <p:txBody>
-          <a:bodyPr/>
-          <a:p/>
-        </p:txBody>
       </p:sp>
       <p:sp>
         <p:nvSpPr>
@@ -4787,10 +4711,6 @@
             <a:prstDash val="solid"/>
           </a:ln>
         </p:spPr>
-        <p:txBody>
-          <a:bodyPr/>
-          <a:p/>
-        </p:txBody>
       </p:sp>
       <p:sp>
         <p:nvSpPr>
@@ -4894,10 +4814,6 @@
           </a:solidFill>
           <a:ln/>
         </p:spPr>
-        <p:txBody>
-          <a:bodyPr/>
-          <a:p/>
-        </p:txBody>
       </p:sp>
       <p:sp>
         <p:nvSpPr>
@@ -5022,10 +4938,6 @@
           </a:solidFill>
           <a:ln/>
         </p:spPr>
-        <p:txBody>
-          <a:bodyPr/>
-          <a:p/>
-        </p:txBody>
       </p:sp>
       <p:sp>
         <p:nvSpPr>
@@ -5046,10 +4958,6 @@
           </a:solidFill>
           <a:ln/>
         </p:spPr>
-        <p:txBody>
-          <a:bodyPr/>
-          <a:p/>
-        </p:txBody>
       </p:sp>
       <p:sp>
         <p:nvSpPr>
@@ -5276,10 +5184,6 @@
             <a:prstDash val="solid"/>
           </a:ln>
         </p:spPr>
-        <p:txBody>
-          <a:bodyPr/>
-          <a:p/>
-        </p:txBody>
       </p:sp>
       <p:sp>
         <p:nvSpPr>
@@ -5347,10 +5251,6 @@
           </a:solidFill>
           <a:ln/>
         </p:spPr>
-        <p:txBody>
-          <a:bodyPr/>
-          <a:p/>
-        </p:txBody>
       </p:sp>
       <p:sp>
         <p:nvSpPr>
@@ -5475,10 +5375,6 @@
           </a:solidFill>
           <a:ln/>
         </p:spPr>
-        <p:txBody>
-          <a:bodyPr/>
-          <a:p/>
-        </p:txBody>
       </p:sp>
       <p:sp>
         <p:nvSpPr>
@@ -5499,10 +5395,6 @@
           </a:solidFill>
           <a:ln/>
         </p:spPr>
-        <p:txBody>
-          <a:bodyPr/>
-          <a:p/>
-        </p:txBody>
       </p:sp>
       <p:sp>
         <p:nvSpPr>
@@ -5602,10 +5494,6 @@
             <a:prstDash val="solid"/>
           </a:ln>
         </p:spPr>
-        <p:txBody>
-          <a:bodyPr/>
-          <a:p/>
-        </p:txBody>
       </p:sp>
       <p:sp>
         <p:nvSpPr>
@@ -5626,10 +5514,6 @@
           </a:solidFill>
           <a:ln/>
         </p:spPr>
-        <p:txBody>
-          <a:bodyPr/>
-          <a:p/>
-        </p:txBody>
       </p:sp>
       <p:sp>
         <p:nvSpPr>
@@ -5765,10 +5649,6 @@
             <a:prstDash val="solid"/>
           </a:ln>
         </p:spPr>
-        <p:txBody>
-          <a:bodyPr/>
-          <a:p/>
-        </p:txBody>
       </p:sp>
       <p:sp>
         <p:nvSpPr>
@@ -5789,10 +5669,6 @@
           </a:solidFill>
           <a:ln/>
         </p:spPr>
-        <p:txBody>
-          <a:bodyPr/>
-          <a:p/>
-        </p:txBody>
       </p:sp>
       <p:sp>
         <p:nvSpPr>
@@ -5928,10 +5804,6 @@
             <a:prstDash val="solid"/>
           </a:ln>
         </p:spPr>
-        <p:txBody>
-          <a:bodyPr/>
-          <a:p/>
-        </p:txBody>
       </p:sp>
       <p:sp>
         <p:nvSpPr>
@@ -5952,10 +5824,6 @@
           </a:solidFill>
           <a:ln/>
         </p:spPr>
-        <p:txBody>
-          <a:bodyPr/>
-          <a:p/>
-        </p:txBody>
       </p:sp>
       <p:sp>
         <p:nvSpPr>
@@ -6091,10 +5959,6 @@
             <a:prstDash val="solid"/>
           </a:ln>
         </p:spPr>
-        <p:txBody>
-          <a:bodyPr/>
-          <a:p/>
-        </p:txBody>
       </p:sp>
       <p:sp>
         <p:nvSpPr>
@@ -6115,10 +5979,6 @@
           </a:solidFill>
           <a:ln/>
         </p:spPr>
-        <p:txBody>
-          <a:bodyPr/>
-          <a:p/>
-        </p:txBody>
       </p:sp>
       <p:sp>
         <p:nvSpPr>
@@ -6247,10 +6107,6 @@
           </a:solidFill>
           <a:ln/>
         </p:spPr>
-        <p:txBody>
-          <a:bodyPr/>
-          <a:p/>
-        </p:txBody>
       </p:sp>
       <p:sp>
         <p:nvSpPr>
@@ -6375,10 +6231,6 @@
           </a:solidFill>
           <a:ln/>
         </p:spPr>
-        <p:txBody>
-          <a:bodyPr/>
-          <a:p/>
-        </p:txBody>
       </p:sp>
       <p:sp>
         <p:nvSpPr>
@@ -6399,10 +6251,6 @@
           </a:solidFill>
           <a:ln/>
         </p:spPr>
-        <p:txBody>
-          <a:bodyPr/>
-          <a:p/>
-        </p:txBody>
       </p:sp>
       <p:sp>
         <p:nvSpPr>
@@ -6629,10 +6477,6 @@
             <a:prstDash val="solid"/>
           </a:ln>
         </p:spPr>
-        <p:txBody>
-          <a:bodyPr/>
-          <a:p/>
-        </p:txBody>
       </p:sp>
       <p:sp>
         <p:nvSpPr>
@@ -6700,10 +6544,6 @@
           </a:solidFill>
           <a:ln/>
         </p:spPr>
-        <p:txBody>
-          <a:bodyPr/>
-          <a:p/>
-        </p:txBody>
       </p:sp>
       <p:sp>
         <p:nvSpPr>
@@ -6828,10 +6668,6 @@
           </a:solidFill>
           <a:ln/>
         </p:spPr>
-        <p:txBody>
-          <a:bodyPr/>
-          <a:p/>
-        </p:txBody>
       </p:sp>
       <p:sp>
         <p:nvSpPr>
@@ -6926,10 +6762,6 @@
           </a:solidFill>
           <a:ln/>
         </p:spPr>
-        <p:txBody>
-          <a:bodyPr/>
-          <a:p/>
-        </p:txBody>
       </p:sp>
       <p:sp>
         <p:nvSpPr>

</xml_diff>